<commit_message>
Sync santiago_2026 with Day 1-2 materials from the workshop Dropbox
Copy the four publishable decks presented Monday (teoria, inferencia
causal, fijar-T-medir-Y, Design Talk 1), fill the D1-2 card, point D1-4
and D1-5 at the 2026 decks, and add a D1-6 card for the Monday workshop
(R session renumbered to D1-7). Update the presentation template to the
Santiago version (title said Montevideo) and add Pellerino's
introduccion deck. The welcome deck and LD_experiment sheet stay out:
participant photos and names. scripts/check_dropbox_sync.sh reports
source-side drift and new files each evening without copying anything.

Co-Authored-By: Claude Fable 5 <noreply@anthropic.com>
Claude-Session: https://claude.ai/code/session_01XrU1na3THhJvtsqm8bPLUi
</commit_message>
<xml_diff>
--- a/santiago_2026/forms/formato-presentacion.pptx
+++ b/santiago_2026/forms/formato-presentacion.pptx
@@ -383,7 +383,7 @@
           <a:p>
             <a:fld id="{3DAA8432-99A1-4342-BB63-4C2AAA4A13FD}" type="datetimeFigureOut">
               <a:rPr lang="en-US" smtClean="0"/>
-              <a:t>7/22/25</a:t>
+              <a:t>7/27/26</a:t>
             </a:fld>
             <a:endParaRPr lang="en-US"/>
           </a:p>
@@ -583,7 +583,7 @@
           <a:p>
             <a:fld id="{3DAA8432-99A1-4342-BB63-4C2AAA4A13FD}" type="datetimeFigureOut">
               <a:rPr lang="en-US" smtClean="0"/>
-              <a:t>7/22/25</a:t>
+              <a:t>7/27/26</a:t>
             </a:fld>
             <a:endParaRPr lang="en-US"/>
           </a:p>
@@ -793,7 +793,7 @@
           <a:p>
             <a:fld id="{3DAA8432-99A1-4342-BB63-4C2AAA4A13FD}" type="datetimeFigureOut">
               <a:rPr lang="en-US" smtClean="0"/>
-              <a:t>7/22/25</a:t>
+              <a:t>7/27/26</a:t>
             </a:fld>
             <a:endParaRPr lang="en-US"/>
           </a:p>
@@ -993,7 +993,7 @@
           <a:p>
             <a:fld id="{3DAA8432-99A1-4342-BB63-4C2AAA4A13FD}" type="datetimeFigureOut">
               <a:rPr lang="en-US" smtClean="0"/>
-              <a:t>7/22/25</a:t>
+              <a:t>7/27/26</a:t>
             </a:fld>
             <a:endParaRPr lang="en-US"/>
           </a:p>
@@ -1269,7 +1269,7 @@
           <a:p>
             <a:fld id="{3DAA8432-99A1-4342-BB63-4C2AAA4A13FD}" type="datetimeFigureOut">
               <a:rPr lang="en-US" smtClean="0"/>
-              <a:t>7/22/25</a:t>
+              <a:t>7/27/26</a:t>
             </a:fld>
             <a:endParaRPr lang="en-US"/>
           </a:p>
@@ -1537,7 +1537,7 @@
           <a:p>
             <a:fld id="{3DAA8432-99A1-4342-BB63-4C2AAA4A13FD}" type="datetimeFigureOut">
               <a:rPr lang="en-US" smtClean="0"/>
-              <a:t>7/22/25</a:t>
+              <a:t>7/27/26</a:t>
             </a:fld>
             <a:endParaRPr lang="en-US"/>
           </a:p>
@@ -1952,7 +1952,7 @@
           <a:p>
             <a:fld id="{3DAA8432-99A1-4342-BB63-4C2AAA4A13FD}" type="datetimeFigureOut">
               <a:rPr lang="en-US" smtClean="0"/>
-              <a:t>7/22/25</a:t>
+              <a:t>7/27/26</a:t>
             </a:fld>
             <a:endParaRPr lang="en-US"/>
           </a:p>
@@ -2094,7 +2094,7 @@
           <a:p>
             <a:fld id="{3DAA8432-99A1-4342-BB63-4C2AAA4A13FD}" type="datetimeFigureOut">
               <a:rPr lang="en-US" smtClean="0"/>
-              <a:t>7/22/25</a:t>
+              <a:t>7/27/26</a:t>
             </a:fld>
             <a:endParaRPr lang="en-US"/>
           </a:p>
@@ -2207,7 +2207,7 @@
           <a:p>
             <a:fld id="{3DAA8432-99A1-4342-BB63-4C2AAA4A13FD}" type="datetimeFigureOut">
               <a:rPr lang="en-US" smtClean="0"/>
-              <a:t>7/22/25</a:t>
+              <a:t>7/27/26</a:t>
             </a:fld>
             <a:endParaRPr lang="en-US"/>
           </a:p>
@@ -2520,7 +2520,7 @@
           <a:p>
             <a:fld id="{3DAA8432-99A1-4342-BB63-4C2AAA4A13FD}" type="datetimeFigureOut">
               <a:rPr lang="en-US" smtClean="0"/>
-              <a:t>7/22/25</a:t>
+              <a:t>7/27/26</a:t>
             </a:fld>
             <a:endParaRPr lang="en-US"/>
           </a:p>
@@ -2809,7 +2809,7 @@
           <a:p>
             <a:fld id="{3DAA8432-99A1-4342-BB63-4C2AAA4A13FD}" type="datetimeFigureOut">
               <a:rPr lang="en-US" smtClean="0"/>
-              <a:t>7/22/25</a:t>
+              <a:t>7/27/26</a:t>
             </a:fld>
             <a:endParaRPr lang="en-US"/>
           </a:p>
@@ -3052,7 +3052,7 @@
           <a:p>
             <a:fld id="{3DAA8432-99A1-4342-BB63-4C2AAA4A13FD}" type="datetimeFigureOut">
               <a:rPr lang="en-US" smtClean="0"/>
-              <a:t>7/22/25</a:t>
+              <a:t>7/27/26</a:t>
             </a:fld>
             <a:endParaRPr lang="en-US"/>
           </a:p>
@@ -3558,7 +3558,7 @@
           <a:p>
             <a:r>
               <a:rPr lang="en-US" dirty="0"/>
-              <a:t>Montevideo, Julio 2025</a:t>
+              <a:t>Santiago, Julio 2026</a:t>
             </a:r>
           </a:p>
         </p:txBody>

</xml_diff>